<commit_message>
Atualiza modelos e permite alterar tamanho da fonte separadamente
</commit_message>
<xml_diff>
--- a/templates/30x10.5/cni.pptx
+++ b/templates/30x10.5/cni.pptx
@@ -4136,8 +4136,8 @@
         </p:nvSpPr>
         <p:spPr bwMode="auto">
           <a:xfrm>
-            <a:off x="4763" y="4676775"/>
-            <a:ext cx="9921875" cy="1631950"/>
+            <a:off x="0" y="4424361"/>
+            <a:ext cx="9906000" cy="954093"/>
           </a:xfrm>
           <a:prstGeom prst="rect">
             <a:avLst/>
@@ -4167,7 +4167,7 @@
           </a:extLst>
         </p:spPr>
         <p:txBody>
-          <a:bodyPr lIns="91426" tIns="45713" rIns="91426" bIns="45713">
+          <a:bodyPr wrap="square" lIns="91426" tIns="45713" rIns="91426" bIns="45713">
             <a:spAutoFit/>
           </a:bodyPr>
           <a:lstStyle>
@@ -4305,225 +4305,6 @@
                 <a:latin typeface="Arial Black" panose="020B0A04020102020204" pitchFamily="34" charset="0"/>
               </a:rPr>
               <a:t>NOME</a:t>
-            </a:r>
-          </a:p>
-          <a:p>
-            <a:pPr algn="ctr" eaLnBrk="1" hangingPunct="1">
-              <a:spcBef>
-                <a:spcPct val="0"/>
-              </a:spcBef>
-              <a:buFontTx/>
-              <a:buNone/>
-            </a:pPr>
-            <a:r>
-              <a:rPr lang="pt-BR" altLang="pt-BR" sz="4000" b="1" dirty="0">
-                <a:latin typeface="Arial Black" panose="020B0A04020102020204" pitchFamily="34" charset="0"/>
-              </a:rPr>
-              <a:t>CARGO</a:t>
-            </a:r>
-          </a:p>
-        </p:txBody>
-      </p:sp>
-      <p:sp>
-        <p:nvSpPr>
-          <p:cNvPr id="3075" name="Text Box 9">
-            <a:extLst>
-              <a:ext uri="{FF2B5EF4-FFF2-40B4-BE49-F238E27FC236}">
-                <a16:creationId xmlns:a16="http://schemas.microsoft.com/office/drawing/2014/main" id="{7FE84379-0892-FCC9-7DED-1D348A2B8E4D}"/>
-              </a:ext>
-            </a:extLst>
-          </p:cNvPr>
-          <p:cNvSpPr txBox="1">
-            <a:spLocks noChangeArrowheads="1"/>
-          </p:cNvSpPr>
-          <p:nvPr/>
-        </p:nvSpPr>
-        <p:spPr bwMode="auto">
-          <a:xfrm flipV="1">
-            <a:off x="-15875" y="549275"/>
-            <a:ext cx="9921875" cy="1631950"/>
-          </a:xfrm>
-          <a:prstGeom prst="rect">
-            <a:avLst/>
-          </a:prstGeom>
-          <a:noFill/>
-          <a:ln>
-            <a:noFill/>
-          </a:ln>
-          <a:extLst>
-            <a:ext uri="{909E8E84-426E-40DD-AFC4-6F175D3DCCD1}">
-              <a14:hiddenFill xmlns:a14="http://schemas.microsoft.com/office/drawing/2010/main">
-                <a:solidFill>
-                  <a:srgbClr val="FFFFFF"/>
-                </a:solidFill>
-              </a14:hiddenFill>
-            </a:ext>
-            <a:ext uri="{91240B29-F687-4F45-9708-019B960494DF}">
-              <a14:hiddenLine xmlns:a14="http://schemas.microsoft.com/office/drawing/2010/main" w="9525">
-                <a:solidFill>
-                  <a:srgbClr val="000000"/>
-                </a:solidFill>
-                <a:miter lim="800000"/>
-                <a:headEnd/>
-                <a:tailEnd/>
-              </a14:hiddenLine>
-            </a:ext>
-          </a:extLst>
-        </p:spPr>
-        <p:txBody>
-          <a:bodyPr lIns="91426" tIns="45713" rIns="91426" bIns="45713">
-            <a:spAutoFit/>
-          </a:bodyPr>
-          <a:lstStyle>
-            <a:lvl1pPr>
-              <a:spcBef>
-                <a:spcPct val="20000"/>
-              </a:spcBef>
-              <a:buChar char="•"/>
-              <a:defRPr sz="3200">
-                <a:solidFill>
-                  <a:schemeClr val="tx1"/>
-                </a:solidFill>
-                <a:latin typeface="Arial" panose="020B0604020202020204" pitchFamily="34" charset="0"/>
-              </a:defRPr>
-            </a:lvl1pPr>
-            <a:lvl2pPr marL="742950" indent="-285750">
-              <a:spcBef>
-                <a:spcPct val="20000"/>
-              </a:spcBef>
-              <a:buChar char="–"/>
-              <a:defRPr sz="2800">
-                <a:solidFill>
-                  <a:schemeClr val="tx1"/>
-                </a:solidFill>
-                <a:latin typeface="Arial" panose="020B0604020202020204" pitchFamily="34" charset="0"/>
-              </a:defRPr>
-            </a:lvl2pPr>
-            <a:lvl3pPr marL="1143000" indent="-228600">
-              <a:spcBef>
-                <a:spcPct val="20000"/>
-              </a:spcBef>
-              <a:buChar char="•"/>
-              <a:defRPr sz="2400">
-                <a:solidFill>
-                  <a:schemeClr val="tx1"/>
-                </a:solidFill>
-                <a:latin typeface="Arial" panose="020B0604020202020204" pitchFamily="34" charset="0"/>
-              </a:defRPr>
-            </a:lvl3pPr>
-            <a:lvl4pPr marL="1600200" indent="-228600">
-              <a:spcBef>
-                <a:spcPct val="20000"/>
-              </a:spcBef>
-              <a:buChar char="–"/>
-              <a:defRPr sz="2000">
-                <a:solidFill>
-                  <a:schemeClr val="tx1"/>
-                </a:solidFill>
-                <a:latin typeface="Arial" panose="020B0604020202020204" pitchFamily="34" charset="0"/>
-              </a:defRPr>
-            </a:lvl4pPr>
-            <a:lvl5pPr marL="2057400" indent="-228600">
-              <a:spcBef>
-                <a:spcPct val="20000"/>
-              </a:spcBef>
-              <a:buChar char="»"/>
-              <a:defRPr sz="2000">
-                <a:solidFill>
-                  <a:schemeClr val="tx1"/>
-                </a:solidFill>
-                <a:latin typeface="Arial" panose="020B0604020202020204" pitchFamily="34" charset="0"/>
-              </a:defRPr>
-            </a:lvl5pPr>
-            <a:lvl6pPr marL="2514600" indent="-228600" eaLnBrk="0" fontAlgn="base" hangingPunct="0">
-              <a:spcBef>
-                <a:spcPct val="20000"/>
-              </a:spcBef>
-              <a:spcAft>
-                <a:spcPct val="0"/>
-              </a:spcAft>
-              <a:buChar char="»"/>
-              <a:defRPr sz="2000">
-                <a:solidFill>
-                  <a:schemeClr val="tx1"/>
-                </a:solidFill>
-                <a:latin typeface="Arial" panose="020B0604020202020204" pitchFamily="34" charset="0"/>
-              </a:defRPr>
-            </a:lvl6pPr>
-            <a:lvl7pPr marL="2971800" indent="-228600" eaLnBrk="0" fontAlgn="base" hangingPunct="0">
-              <a:spcBef>
-                <a:spcPct val="20000"/>
-              </a:spcBef>
-              <a:spcAft>
-                <a:spcPct val="0"/>
-              </a:spcAft>
-              <a:buChar char="»"/>
-              <a:defRPr sz="2000">
-                <a:solidFill>
-                  <a:schemeClr val="tx1"/>
-                </a:solidFill>
-                <a:latin typeface="Arial" panose="020B0604020202020204" pitchFamily="34" charset="0"/>
-              </a:defRPr>
-            </a:lvl7pPr>
-            <a:lvl8pPr marL="3429000" indent="-228600" eaLnBrk="0" fontAlgn="base" hangingPunct="0">
-              <a:spcBef>
-                <a:spcPct val="20000"/>
-              </a:spcBef>
-              <a:spcAft>
-                <a:spcPct val="0"/>
-              </a:spcAft>
-              <a:buChar char="»"/>
-              <a:defRPr sz="2000">
-                <a:solidFill>
-                  <a:schemeClr val="tx1"/>
-                </a:solidFill>
-                <a:latin typeface="Arial" panose="020B0604020202020204" pitchFamily="34" charset="0"/>
-              </a:defRPr>
-            </a:lvl8pPr>
-            <a:lvl9pPr marL="3886200" indent="-228600" eaLnBrk="0" fontAlgn="base" hangingPunct="0">
-              <a:spcBef>
-                <a:spcPct val="20000"/>
-              </a:spcBef>
-              <a:spcAft>
-                <a:spcPct val="0"/>
-              </a:spcAft>
-              <a:buChar char="»"/>
-              <a:defRPr sz="2000">
-                <a:solidFill>
-                  <a:schemeClr val="tx1"/>
-                </a:solidFill>
-                <a:latin typeface="Arial" panose="020B0604020202020204" pitchFamily="34" charset="0"/>
-              </a:defRPr>
-            </a:lvl9pPr>
-          </a:lstStyle>
-          <a:p>
-            <a:pPr algn="ctr" eaLnBrk="1" hangingPunct="1">
-              <a:spcBef>
-                <a:spcPct val="0"/>
-              </a:spcBef>
-              <a:buFontTx/>
-              <a:buNone/>
-            </a:pPr>
-            <a:r>
-              <a:rPr lang="pt-BR" altLang="pt-BR" sz="5600" b="1" dirty="0">
-                <a:latin typeface="Arial Black" panose="020B0A04020102020204" pitchFamily="34" charset="0"/>
-              </a:rPr>
-              <a:t>NOME</a:t>
-            </a:r>
-          </a:p>
-          <a:p>
-            <a:pPr algn="ctr" eaLnBrk="1" hangingPunct="1">
-              <a:spcBef>
-                <a:spcPct val="0"/>
-              </a:spcBef>
-              <a:buFontTx/>
-              <a:buNone/>
-            </a:pPr>
-            <a:r>
-              <a:rPr lang="pt-BR" altLang="pt-BR" sz="4000" b="1" dirty="0">
-                <a:latin typeface="Arial Black" panose="020B0A04020102020204" pitchFamily="34" charset="0"/>
-              </a:rPr>
-              <a:t>CARGO</a:t>
             </a:r>
           </a:p>
         </p:txBody>
@@ -4828,6 +4609,951 @@
           </a:extLst>
         </p:spPr>
       </p:pic>
+      <p:sp>
+        <p:nvSpPr>
+          <p:cNvPr id="4" name="Text Box 9">
+            <a:extLst>
+              <a:ext uri="{FF2B5EF4-FFF2-40B4-BE49-F238E27FC236}">
+                <a16:creationId xmlns:a16="http://schemas.microsoft.com/office/drawing/2014/main" id="{2EA6D9E3-6B27-ED00-E8F9-3786445DB311}"/>
+              </a:ext>
+            </a:extLst>
+          </p:cNvPr>
+          <p:cNvSpPr txBox="1">
+            <a:spLocks noChangeArrowheads="1"/>
+          </p:cNvSpPr>
+          <p:nvPr/>
+        </p:nvSpPr>
+        <p:spPr bwMode="auto">
+          <a:xfrm>
+            <a:off x="-15876" y="5184689"/>
+            <a:ext cx="9921875" cy="707872"/>
+          </a:xfrm>
+          <a:prstGeom prst="rect">
+            <a:avLst/>
+          </a:prstGeom>
+          <a:noFill/>
+          <a:ln>
+            <a:noFill/>
+          </a:ln>
+          <a:extLst>
+            <a:ext uri="{909E8E84-426E-40DD-AFC4-6F175D3DCCD1}">
+              <a14:hiddenFill xmlns:a14="http://schemas.microsoft.com/office/drawing/2010/main">
+                <a:solidFill>
+                  <a:srgbClr val="FFFFFF"/>
+                </a:solidFill>
+              </a14:hiddenFill>
+            </a:ext>
+            <a:ext uri="{91240B29-F687-4F45-9708-019B960494DF}">
+              <a14:hiddenLine xmlns:a14="http://schemas.microsoft.com/office/drawing/2010/main" w="9525">
+                <a:solidFill>
+                  <a:srgbClr val="000000"/>
+                </a:solidFill>
+                <a:miter lim="800000"/>
+                <a:headEnd/>
+                <a:tailEnd/>
+              </a14:hiddenLine>
+            </a:ext>
+          </a:extLst>
+        </p:spPr>
+        <p:txBody>
+          <a:bodyPr lIns="91426" tIns="45713" rIns="91426" bIns="45713">
+            <a:spAutoFit/>
+          </a:bodyPr>
+          <a:lstStyle>
+            <a:lvl1pPr>
+              <a:spcBef>
+                <a:spcPct val="20000"/>
+              </a:spcBef>
+              <a:buChar char="•"/>
+              <a:defRPr sz="3200">
+                <a:solidFill>
+                  <a:schemeClr val="tx1"/>
+                </a:solidFill>
+                <a:latin typeface="Arial" panose="020B0604020202020204" pitchFamily="34" charset="0"/>
+              </a:defRPr>
+            </a:lvl1pPr>
+            <a:lvl2pPr marL="742950" indent="-285750">
+              <a:spcBef>
+                <a:spcPct val="20000"/>
+              </a:spcBef>
+              <a:buChar char="–"/>
+              <a:defRPr sz="2800">
+                <a:solidFill>
+                  <a:schemeClr val="tx1"/>
+                </a:solidFill>
+                <a:latin typeface="Arial" panose="020B0604020202020204" pitchFamily="34" charset="0"/>
+              </a:defRPr>
+            </a:lvl2pPr>
+            <a:lvl3pPr marL="1143000" indent="-228600">
+              <a:spcBef>
+                <a:spcPct val="20000"/>
+              </a:spcBef>
+              <a:buChar char="•"/>
+              <a:defRPr sz="2400">
+                <a:solidFill>
+                  <a:schemeClr val="tx1"/>
+                </a:solidFill>
+                <a:latin typeface="Arial" panose="020B0604020202020204" pitchFamily="34" charset="0"/>
+              </a:defRPr>
+            </a:lvl3pPr>
+            <a:lvl4pPr marL="1600200" indent="-228600">
+              <a:spcBef>
+                <a:spcPct val="20000"/>
+              </a:spcBef>
+              <a:buChar char="–"/>
+              <a:defRPr sz="2000">
+                <a:solidFill>
+                  <a:schemeClr val="tx1"/>
+                </a:solidFill>
+                <a:latin typeface="Arial" panose="020B0604020202020204" pitchFamily="34" charset="0"/>
+              </a:defRPr>
+            </a:lvl4pPr>
+            <a:lvl5pPr marL="2057400" indent="-228600">
+              <a:spcBef>
+                <a:spcPct val="20000"/>
+              </a:spcBef>
+              <a:buChar char="»"/>
+              <a:defRPr sz="2000">
+                <a:solidFill>
+                  <a:schemeClr val="tx1"/>
+                </a:solidFill>
+                <a:latin typeface="Arial" panose="020B0604020202020204" pitchFamily="34" charset="0"/>
+              </a:defRPr>
+            </a:lvl5pPr>
+            <a:lvl6pPr marL="2514600" indent="-228600" eaLnBrk="0" fontAlgn="base" hangingPunct="0">
+              <a:spcBef>
+                <a:spcPct val="20000"/>
+              </a:spcBef>
+              <a:spcAft>
+                <a:spcPct val="0"/>
+              </a:spcAft>
+              <a:buChar char="»"/>
+              <a:defRPr sz="2000">
+                <a:solidFill>
+                  <a:schemeClr val="tx1"/>
+                </a:solidFill>
+                <a:latin typeface="Arial" panose="020B0604020202020204" pitchFamily="34" charset="0"/>
+              </a:defRPr>
+            </a:lvl6pPr>
+            <a:lvl7pPr marL="2971800" indent="-228600" eaLnBrk="0" fontAlgn="base" hangingPunct="0">
+              <a:spcBef>
+                <a:spcPct val="20000"/>
+              </a:spcBef>
+              <a:spcAft>
+                <a:spcPct val="0"/>
+              </a:spcAft>
+              <a:buChar char="»"/>
+              <a:defRPr sz="2000">
+                <a:solidFill>
+                  <a:schemeClr val="tx1"/>
+                </a:solidFill>
+                <a:latin typeface="Arial" panose="020B0604020202020204" pitchFamily="34" charset="0"/>
+              </a:defRPr>
+            </a:lvl7pPr>
+            <a:lvl8pPr marL="3429000" indent="-228600" eaLnBrk="0" fontAlgn="base" hangingPunct="0">
+              <a:spcBef>
+                <a:spcPct val="20000"/>
+              </a:spcBef>
+              <a:spcAft>
+                <a:spcPct val="0"/>
+              </a:spcAft>
+              <a:buChar char="»"/>
+              <a:defRPr sz="2000">
+                <a:solidFill>
+                  <a:schemeClr val="tx1"/>
+                </a:solidFill>
+                <a:latin typeface="Arial" panose="020B0604020202020204" pitchFamily="34" charset="0"/>
+              </a:defRPr>
+            </a:lvl8pPr>
+            <a:lvl9pPr marL="3886200" indent="-228600" eaLnBrk="0" fontAlgn="base" hangingPunct="0">
+              <a:spcBef>
+                <a:spcPct val="20000"/>
+              </a:spcBef>
+              <a:spcAft>
+                <a:spcPct val="0"/>
+              </a:spcAft>
+              <a:buChar char="»"/>
+              <a:defRPr sz="2000">
+                <a:solidFill>
+                  <a:schemeClr val="tx1"/>
+                </a:solidFill>
+                <a:latin typeface="Arial" panose="020B0604020202020204" pitchFamily="34" charset="0"/>
+              </a:defRPr>
+            </a:lvl9pPr>
+          </a:lstStyle>
+          <a:p>
+            <a:pPr algn="ctr" eaLnBrk="1" hangingPunct="1">
+              <a:spcBef>
+                <a:spcPct val="0"/>
+              </a:spcBef>
+              <a:buFontTx/>
+              <a:buNone/>
+            </a:pPr>
+            <a:r>
+              <a:rPr lang="pt-BR" altLang="pt-BR" sz="4000" b="1" dirty="0">
+                <a:latin typeface="Arial Black" panose="020B0A04020102020204" pitchFamily="34" charset="0"/>
+              </a:rPr>
+              <a:t>CARGO</a:t>
+            </a:r>
+          </a:p>
+        </p:txBody>
+      </p:sp>
+      <p:sp>
+        <p:nvSpPr>
+          <p:cNvPr id="8" name="Text Box 9">
+            <a:extLst>
+              <a:ext uri="{FF2B5EF4-FFF2-40B4-BE49-F238E27FC236}">
+                <a16:creationId xmlns:a16="http://schemas.microsoft.com/office/drawing/2014/main" id="{61F04680-D62A-7DE1-395E-620CEFCA605A}"/>
+              </a:ext>
+            </a:extLst>
+          </p:cNvPr>
+          <p:cNvSpPr txBox="1">
+            <a:spLocks noChangeArrowheads="1"/>
+          </p:cNvSpPr>
+          <p:nvPr/>
+        </p:nvSpPr>
+        <p:spPr bwMode="auto">
+          <a:xfrm>
+            <a:off x="-1" y="5726909"/>
+            <a:ext cx="9921875" cy="707872"/>
+          </a:xfrm>
+          <a:prstGeom prst="rect">
+            <a:avLst/>
+          </a:prstGeom>
+          <a:noFill/>
+          <a:ln>
+            <a:noFill/>
+          </a:ln>
+          <a:extLst>
+            <a:ext uri="{909E8E84-426E-40DD-AFC4-6F175D3DCCD1}">
+              <a14:hiddenFill xmlns:a14="http://schemas.microsoft.com/office/drawing/2010/main">
+                <a:solidFill>
+                  <a:srgbClr val="FFFFFF"/>
+                </a:solidFill>
+              </a14:hiddenFill>
+            </a:ext>
+            <a:ext uri="{91240B29-F687-4F45-9708-019B960494DF}">
+              <a14:hiddenLine xmlns:a14="http://schemas.microsoft.com/office/drawing/2010/main" w="9525">
+                <a:solidFill>
+                  <a:srgbClr val="000000"/>
+                </a:solidFill>
+                <a:miter lim="800000"/>
+                <a:headEnd/>
+                <a:tailEnd/>
+              </a14:hiddenLine>
+            </a:ext>
+          </a:extLst>
+        </p:spPr>
+        <p:txBody>
+          <a:bodyPr lIns="91426" tIns="45713" rIns="91426" bIns="45713">
+            <a:spAutoFit/>
+          </a:bodyPr>
+          <a:lstStyle>
+            <a:lvl1pPr>
+              <a:spcBef>
+                <a:spcPct val="20000"/>
+              </a:spcBef>
+              <a:buChar char="•"/>
+              <a:defRPr sz="3200">
+                <a:solidFill>
+                  <a:schemeClr val="tx1"/>
+                </a:solidFill>
+                <a:latin typeface="Arial" panose="020B0604020202020204" pitchFamily="34" charset="0"/>
+              </a:defRPr>
+            </a:lvl1pPr>
+            <a:lvl2pPr marL="742950" indent="-285750">
+              <a:spcBef>
+                <a:spcPct val="20000"/>
+              </a:spcBef>
+              <a:buChar char="–"/>
+              <a:defRPr sz="2800">
+                <a:solidFill>
+                  <a:schemeClr val="tx1"/>
+                </a:solidFill>
+                <a:latin typeface="Arial" panose="020B0604020202020204" pitchFamily="34" charset="0"/>
+              </a:defRPr>
+            </a:lvl2pPr>
+            <a:lvl3pPr marL="1143000" indent="-228600">
+              <a:spcBef>
+                <a:spcPct val="20000"/>
+              </a:spcBef>
+              <a:buChar char="•"/>
+              <a:defRPr sz="2400">
+                <a:solidFill>
+                  <a:schemeClr val="tx1"/>
+                </a:solidFill>
+                <a:latin typeface="Arial" panose="020B0604020202020204" pitchFamily="34" charset="0"/>
+              </a:defRPr>
+            </a:lvl3pPr>
+            <a:lvl4pPr marL="1600200" indent="-228600">
+              <a:spcBef>
+                <a:spcPct val="20000"/>
+              </a:spcBef>
+              <a:buChar char="–"/>
+              <a:defRPr sz="2000">
+                <a:solidFill>
+                  <a:schemeClr val="tx1"/>
+                </a:solidFill>
+                <a:latin typeface="Arial" panose="020B0604020202020204" pitchFamily="34" charset="0"/>
+              </a:defRPr>
+            </a:lvl4pPr>
+            <a:lvl5pPr marL="2057400" indent="-228600">
+              <a:spcBef>
+                <a:spcPct val="20000"/>
+              </a:spcBef>
+              <a:buChar char="»"/>
+              <a:defRPr sz="2000">
+                <a:solidFill>
+                  <a:schemeClr val="tx1"/>
+                </a:solidFill>
+                <a:latin typeface="Arial" panose="020B0604020202020204" pitchFamily="34" charset="0"/>
+              </a:defRPr>
+            </a:lvl5pPr>
+            <a:lvl6pPr marL="2514600" indent="-228600" eaLnBrk="0" fontAlgn="base" hangingPunct="0">
+              <a:spcBef>
+                <a:spcPct val="20000"/>
+              </a:spcBef>
+              <a:spcAft>
+                <a:spcPct val="0"/>
+              </a:spcAft>
+              <a:buChar char="»"/>
+              <a:defRPr sz="2000">
+                <a:solidFill>
+                  <a:schemeClr val="tx1"/>
+                </a:solidFill>
+                <a:latin typeface="Arial" panose="020B0604020202020204" pitchFamily="34" charset="0"/>
+              </a:defRPr>
+            </a:lvl6pPr>
+            <a:lvl7pPr marL="2971800" indent="-228600" eaLnBrk="0" fontAlgn="base" hangingPunct="0">
+              <a:spcBef>
+                <a:spcPct val="20000"/>
+              </a:spcBef>
+              <a:spcAft>
+                <a:spcPct val="0"/>
+              </a:spcAft>
+              <a:buChar char="»"/>
+              <a:defRPr sz="2000">
+                <a:solidFill>
+                  <a:schemeClr val="tx1"/>
+                </a:solidFill>
+                <a:latin typeface="Arial" panose="020B0604020202020204" pitchFamily="34" charset="0"/>
+              </a:defRPr>
+            </a:lvl7pPr>
+            <a:lvl8pPr marL="3429000" indent="-228600" eaLnBrk="0" fontAlgn="base" hangingPunct="0">
+              <a:spcBef>
+                <a:spcPct val="20000"/>
+              </a:spcBef>
+              <a:spcAft>
+                <a:spcPct val="0"/>
+              </a:spcAft>
+              <a:buChar char="»"/>
+              <a:defRPr sz="2000">
+                <a:solidFill>
+                  <a:schemeClr val="tx1"/>
+                </a:solidFill>
+                <a:latin typeface="Arial" panose="020B0604020202020204" pitchFamily="34" charset="0"/>
+              </a:defRPr>
+            </a:lvl8pPr>
+            <a:lvl9pPr marL="3886200" indent="-228600" eaLnBrk="0" fontAlgn="base" hangingPunct="0">
+              <a:spcBef>
+                <a:spcPct val="20000"/>
+              </a:spcBef>
+              <a:spcAft>
+                <a:spcPct val="0"/>
+              </a:spcAft>
+              <a:buChar char="»"/>
+              <a:defRPr sz="2000">
+                <a:solidFill>
+                  <a:schemeClr val="tx1"/>
+                </a:solidFill>
+                <a:latin typeface="Arial" panose="020B0604020202020204" pitchFamily="34" charset="0"/>
+              </a:defRPr>
+            </a:lvl9pPr>
+          </a:lstStyle>
+          <a:p>
+            <a:pPr algn="ctr" eaLnBrk="1" hangingPunct="1">
+              <a:spcBef>
+                <a:spcPct val="0"/>
+              </a:spcBef>
+              <a:buFontTx/>
+              <a:buNone/>
+            </a:pPr>
+            <a:r>
+              <a:rPr lang="pt-BR" altLang="pt-BR" sz="4000" b="1" dirty="0">
+                <a:latin typeface="Arial Black" panose="020B0A04020102020204" pitchFamily="34" charset="0"/>
+              </a:rPr>
+              <a:t>EMPRESA</a:t>
+            </a:r>
+          </a:p>
+        </p:txBody>
+      </p:sp>
+      <p:sp>
+        <p:nvSpPr>
+          <p:cNvPr id="10" name="Text Box 9">
+            <a:extLst>
+              <a:ext uri="{FF2B5EF4-FFF2-40B4-BE49-F238E27FC236}">
+                <a16:creationId xmlns:a16="http://schemas.microsoft.com/office/drawing/2014/main" id="{FBE90B7F-7B83-D1CB-C307-2F4EB9DC5440}"/>
+              </a:ext>
+            </a:extLst>
+          </p:cNvPr>
+          <p:cNvSpPr txBox="1">
+            <a:spLocks noChangeArrowheads="1"/>
+          </p:cNvSpPr>
+          <p:nvPr/>
+        </p:nvSpPr>
+        <p:spPr bwMode="auto">
+          <a:xfrm flipV="1">
+            <a:off x="-15876" y="360859"/>
+            <a:ext cx="9921875" cy="707872"/>
+          </a:xfrm>
+          <a:prstGeom prst="rect">
+            <a:avLst/>
+          </a:prstGeom>
+          <a:noFill/>
+          <a:ln>
+            <a:noFill/>
+          </a:ln>
+          <a:extLst>
+            <a:ext uri="{909E8E84-426E-40DD-AFC4-6F175D3DCCD1}">
+              <a14:hiddenFill xmlns:a14="http://schemas.microsoft.com/office/drawing/2010/main">
+                <a:solidFill>
+                  <a:srgbClr val="FFFFFF"/>
+                </a:solidFill>
+              </a14:hiddenFill>
+            </a:ext>
+            <a:ext uri="{91240B29-F687-4F45-9708-019B960494DF}">
+              <a14:hiddenLine xmlns:a14="http://schemas.microsoft.com/office/drawing/2010/main" w="9525">
+                <a:solidFill>
+                  <a:srgbClr val="000000"/>
+                </a:solidFill>
+                <a:miter lim="800000"/>
+                <a:headEnd/>
+                <a:tailEnd/>
+              </a14:hiddenLine>
+            </a:ext>
+          </a:extLst>
+        </p:spPr>
+        <p:txBody>
+          <a:bodyPr lIns="91426" tIns="45713" rIns="91426" bIns="45713">
+            <a:spAutoFit/>
+          </a:bodyPr>
+          <a:lstStyle>
+            <a:lvl1pPr>
+              <a:spcBef>
+                <a:spcPct val="20000"/>
+              </a:spcBef>
+              <a:buChar char="•"/>
+              <a:defRPr sz="3200">
+                <a:solidFill>
+                  <a:schemeClr val="tx1"/>
+                </a:solidFill>
+                <a:latin typeface="Arial" panose="020B0604020202020204" pitchFamily="34" charset="0"/>
+              </a:defRPr>
+            </a:lvl1pPr>
+            <a:lvl2pPr marL="742950" indent="-285750">
+              <a:spcBef>
+                <a:spcPct val="20000"/>
+              </a:spcBef>
+              <a:buChar char="–"/>
+              <a:defRPr sz="2800">
+                <a:solidFill>
+                  <a:schemeClr val="tx1"/>
+                </a:solidFill>
+                <a:latin typeface="Arial" panose="020B0604020202020204" pitchFamily="34" charset="0"/>
+              </a:defRPr>
+            </a:lvl2pPr>
+            <a:lvl3pPr marL="1143000" indent="-228600">
+              <a:spcBef>
+                <a:spcPct val="20000"/>
+              </a:spcBef>
+              <a:buChar char="•"/>
+              <a:defRPr sz="2400">
+                <a:solidFill>
+                  <a:schemeClr val="tx1"/>
+                </a:solidFill>
+                <a:latin typeface="Arial" panose="020B0604020202020204" pitchFamily="34" charset="0"/>
+              </a:defRPr>
+            </a:lvl3pPr>
+            <a:lvl4pPr marL="1600200" indent="-228600">
+              <a:spcBef>
+                <a:spcPct val="20000"/>
+              </a:spcBef>
+              <a:buChar char="–"/>
+              <a:defRPr sz="2000">
+                <a:solidFill>
+                  <a:schemeClr val="tx1"/>
+                </a:solidFill>
+                <a:latin typeface="Arial" panose="020B0604020202020204" pitchFamily="34" charset="0"/>
+              </a:defRPr>
+            </a:lvl4pPr>
+            <a:lvl5pPr marL="2057400" indent="-228600">
+              <a:spcBef>
+                <a:spcPct val="20000"/>
+              </a:spcBef>
+              <a:buChar char="»"/>
+              <a:defRPr sz="2000">
+                <a:solidFill>
+                  <a:schemeClr val="tx1"/>
+                </a:solidFill>
+                <a:latin typeface="Arial" panose="020B0604020202020204" pitchFamily="34" charset="0"/>
+              </a:defRPr>
+            </a:lvl5pPr>
+            <a:lvl6pPr marL="2514600" indent="-228600" eaLnBrk="0" fontAlgn="base" hangingPunct="0">
+              <a:spcBef>
+                <a:spcPct val="20000"/>
+              </a:spcBef>
+              <a:spcAft>
+                <a:spcPct val="0"/>
+              </a:spcAft>
+              <a:buChar char="»"/>
+              <a:defRPr sz="2000">
+                <a:solidFill>
+                  <a:schemeClr val="tx1"/>
+                </a:solidFill>
+                <a:latin typeface="Arial" panose="020B0604020202020204" pitchFamily="34" charset="0"/>
+              </a:defRPr>
+            </a:lvl6pPr>
+            <a:lvl7pPr marL="2971800" indent="-228600" eaLnBrk="0" fontAlgn="base" hangingPunct="0">
+              <a:spcBef>
+                <a:spcPct val="20000"/>
+              </a:spcBef>
+              <a:spcAft>
+                <a:spcPct val="0"/>
+              </a:spcAft>
+              <a:buChar char="»"/>
+              <a:defRPr sz="2000">
+                <a:solidFill>
+                  <a:schemeClr val="tx1"/>
+                </a:solidFill>
+                <a:latin typeface="Arial" panose="020B0604020202020204" pitchFamily="34" charset="0"/>
+              </a:defRPr>
+            </a:lvl7pPr>
+            <a:lvl8pPr marL="3429000" indent="-228600" eaLnBrk="0" fontAlgn="base" hangingPunct="0">
+              <a:spcBef>
+                <a:spcPct val="20000"/>
+              </a:spcBef>
+              <a:spcAft>
+                <a:spcPct val="0"/>
+              </a:spcAft>
+              <a:buChar char="»"/>
+              <a:defRPr sz="2000">
+                <a:solidFill>
+                  <a:schemeClr val="tx1"/>
+                </a:solidFill>
+                <a:latin typeface="Arial" panose="020B0604020202020204" pitchFamily="34" charset="0"/>
+              </a:defRPr>
+            </a:lvl8pPr>
+            <a:lvl9pPr marL="3886200" indent="-228600" eaLnBrk="0" fontAlgn="base" hangingPunct="0">
+              <a:spcBef>
+                <a:spcPct val="20000"/>
+              </a:spcBef>
+              <a:spcAft>
+                <a:spcPct val="0"/>
+              </a:spcAft>
+              <a:buChar char="»"/>
+              <a:defRPr sz="2000">
+                <a:solidFill>
+                  <a:schemeClr val="tx1"/>
+                </a:solidFill>
+                <a:latin typeface="Arial" panose="020B0604020202020204" pitchFamily="34" charset="0"/>
+              </a:defRPr>
+            </a:lvl9pPr>
+          </a:lstStyle>
+          <a:p>
+            <a:pPr algn="ctr" eaLnBrk="1" hangingPunct="1">
+              <a:spcBef>
+                <a:spcPct val="0"/>
+              </a:spcBef>
+              <a:buFontTx/>
+              <a:buNone/>
+            </a:pPr>
+            <a:r>
+              <a:rPr lang="pt-BR" altLang="pt-BR" sz="4000" b="1" dirty="0">
+                <a:latin typeface="Arial Black" panose="020B0A04020102020204" pitchFamily="34" charset="0"/>
+              </a:rPr>
+              <a:t>EMPRESA</a:t>
+            </a:r>
+          </a:p>
+        </p:txBody>
+      </p:sp>
+      <p:sp>
+        <p:nvSpPr>
+          <p:cNvPr id="12" name="Text Box 9">
+            <a:extLst>
+              <a:ext uri="{FF2B5EF4-FFF2-40B4-BE49-F238E27FC236}">
+                <a16:creationId xmlns:a16="http://schemas.microsoft.com/office/drawing/2014/main" id="{30D8F770-B6F6-2A75-E211-671EA3E01BAF}"/>
+              </a:ext>
+            </a:extLst>
+          </p:cNvPr>
+          <p:cNvSpPr txBox="1">
+            <a:spLocks noChangeArrowheads="1"/>
+          </p:cNvSpPr>
+          <p:nvPr/>
+        </p:nvSpPr>
+        <p:spPr bwMode="auto">
+          <a:xfrm flipV="1">
+            <a:off x="-15876" y="930692"/>
+            <a:ext cx="9921875" cy="707872"/>
+          </a:xfrm>
+          <a:prstGeom prst="rect">
+            <a:avLst/>
+          </a:prstGeom>
+          <a:noFill/>
+          <a:ln>
+            <a:noFill/>
+          </a:ln>
+          <a:extLst>
+            <a:ext uri="{909E8E84-426E-40DD-AFC4-6F175D3DCCD1}">
+              <a14:hiddenFill xmlns:a14="http://schemas.microsoft.com/office/drawing/2010/main">
+                <a:solidFill>
+                  <a:srgbClr val="FFFFFF"/>
+                </a:solidFill>
+              </a14:hiddenFill>
+            </a:ext>
+            <a:ext uri="{91240B29-F687-4F45-9708-019B960494DF}">
+              <a14:hiddenLine xmlns:a14="http://schemas.microsoft.com/office/drawing/2010/main" w="9525">
+                <a:solidFill>
+                  <a:srgbClr val="000000"/>
+                </a:solidFill>
+                <a:miter lim="800000"/>
+                <a:headEnd/>
+                <a:tailEnd/>
+              </a14:hiddenLine>
+            </a:ext>
+          </a:extLst>
+        </p:spPr>
+        <p:txBody>
+          <a:bodyPr lIns="91426" tIns="45713" rIns="91426" bIns="45713">
+            <a:spAutoFit/>
+          </a:bodyPr>
+          <a:lstStyle>
+            <a:lvl1pPr>
+              <a:spcBef>
+                <a:spcPct val="20000"/>
+              </a:spcBef>
+              <a:buChar char="•"/>
+              <a:defRPr sz="3200">
+                <a:solidFill>
+                  <a:schemeClr val="tx1"/>
+                </a:solidFill>
+                <a:latin typeface="Arial" panose="020B0604020202020204" pitchFamily="34" charset="0"/>
+              </a:defRPr>
+            </a:lvl1pPr>
+            <a:lvl2pPr marL="742950" indent="-285750">
+              <a:spcBef>
+                <a:spcPct val="20000"/>
+              </a:spcBef>
+              <a:buChar char="–"/>
+              <a:defRPr sz="2800">
+                <a:solidFill>
+                  <a:schemeClr val="tx1"/>
+                </a:solidFill>
+                <a:latin typeface="Arial" panose="020B0604020202020204" pitchFamily="34" charset="0"/>
+              </a:defRPr>
+            </a:lvl2pPr>
+            <a:lvl3pPr marL="1143000" indent="-228600">
+              <a:spcBef>
+                <a:spcPct val="20000"/>
+              </a:spcBef>
+              <a:buChar char="•"/>
+              <a:defRPr sz="2400">
+                <a:solidFill>
+                  <a:schemeClr val="tx1"/>
+                </a:solidFill>
+                <a:latin typeface="Arial" panose="020B0604020202020204" pitchFamily="34" charset="0"/>
+              </a:defRPr>
+            </a:lvl3pPr>
+            <a:lvl4pPr marL="1600200" indent="-228600">
+              <a:spcBef>
+                <a:spcPct val="20000"/>
+              </a:spcBef>
+              <a:buChar char="–"/>
+              <a:defRPr sz="2000">
+                <a:solidFill>
+                  <a:schemeClr val="tx1"/>
+                </a:solidFill>
+                <a:latin typeface="Arial" panose="020B0604020202020204" pitchFamily="34" charset="0"/>
+              </a:defRPr>
+            </a:lvl4pPr>
+            <a:lvl5pPr marL="2057400" indent="-228600">
+              <a:spcBef>
+                <a:spcPct val="20000"/>
+              </a:spcBef>
+              <a:buChar char="»"/>
+              <a:defRPr sz="2000">
+                <a:solidFill>
+                  <a:schemeClr val="tx1"/>
+                </a:solidFill>
+                <a:latin typeface="Arial" panose="020B0604020202020204" pitchFamily="34" charset="0"/>
+              </a:defRPr>
+            </a:lvl5pPr>
+            <a:lvl6pPr marL="2514600" indent="-228600" eaLnBrk="0" fontAlgn="base" hangingPunct="0">
+              <a:spcBef>
+                <a:spcPct val="20000"/>
+              </a:spcBef>
+              <a:spcAft>
+                <a:spcPct val="0"/>
+              </a:spcAft>
+              <a:buChar char="»"/>
+              <a:defRPr sz="2000">
+                <a:solidFill>
+                  <a:schemeClr val="tx1"/>
+                </a:solidFill>
+                <a:latin typeface="Arial" panose="020B0604020202020204" pitchFamily="34" charset="0"/>
+              </a:defRPr>
+            </a:lvl6pPr>
+            <a:lvl7pPr marL="2971800" indent="-228600" eaLnBrk="0" fontAlgn="base" hangingPunct="0">
+              <a:spcBef>
+                <a:spcPct val="20000"/>
+              </a:spcBef>
+              <a:spcAft>
+                <a:spcPct val="0"/>
+              </a:spcAft>
+              <a:buChar char="»"/>
+              <a:defRPr sz="2000">
+                <a:solidFill>
+                  <a:schemeClr val="tx1"/>
+                </a:solidFill>
+                <a:latin typeface="Arial" panose="020B0604020202020204" pitchFamily="34" charset="0"/>
+              </a:defRPr>
+            </a:lvl7pPr>
+            <a:lvl8pPr marL="3429000" indent="-228600" eaLnBrk="0" fontAlgn="base" hangingPunct="0">
+              <a:spcBef>
+                <a:spcPct val="20000"/>
+              </a:spcBef>
+              <a:spcAft>
+                <a:spcPct val="0"/>
+              </a:spcAft>
+              <a:buChar char="»"/>
+              <a:defRPr sz="2000">
+                <a:solidFill>
+                  <a:schemeClr val="tx1"/>
+                </a:solidFill>
+                <a:latin typeface="Arial" panose="020B0604020202020204" pitchFamily="34" charset="0"/>
+              </a:defRPr>
+            </a:lvl8pPr>
+            <a:lvl9pPr marL="3886200" indent="-228600" eaLnBrk="0" fontAlgn="base" hangingPunct="0">
+              <a:spcBef>
+                <a:spcPct val="20000"/>
+              </a:spcBef>
+              <a:spcAft>
+                <a:spcPct val="0"/>
+              </a:spcAft>
+              <a:buChar char="»"/>
+              <a:defRPr sz="2000">
+                <a:solidFill>
+                  <a:schemeClr val="tx1"/>
+                </a:solidFill>
+                <a:latin typeface="Arial" panose="020B0604020202020204" pitchFamily="34" charset="0"/>
+              </a:defRPr>
+            </a:lvl9pPr>
+          </a:lstStyle>
+          <a:p>
+            <a:pPr algn="ctr" eaLnBrk="1" hangingPunct="1">
+              <a:spcBef>
+                <a:spcPct val="0"/>
+              </a:spcBef>
+              <a:buFontTx/>
+              <a:buNone/>
+            </a:pPr>
+            <a:r>
+              <a:rPr lang="pt-BR" altLang="pt-BR" sz="4000" b="1" dirty="0">
+                <a:latin typeface="Arial Black" panose="020B0A04020102020204" pitchFamily="34" charset="0"/>
+              </a:rPr>
+              <a:t>CARGO</a:t>
+            </a:r>
+          </a:p>
+        </p:txBody>
+      </p:sp>
+      <p:sp>
+        <p:nvSpPr>
+          <p:cNvPr id="14" name="Text Box 9">
+            <a:extLst>
+              <a:ext uri="{FF2B5EF4-FFF2-40B4-BE49-F238E27FC236}">
+                <a16:creationId xmlns:a16="http://schemas.microsoft.com/office/drawing/2014/main" id="{779E6A6B-38C1-37A9-BACD-EF6834E7572B}"/>
+              </a:ext>
+            </a:extLst>
+          </p:cNvPr>
+          <p:cNvSpPr txBox="1">
+            <a:spLocks noChangeArrowheads="1"/>
+          </p:cNvSpPr>
+          <p:nvPr/>
+        </p:nvSpPr>
+        <p:spPr bwMode="auto">
+          <a:xfrm flipV="1">
+            <a:off x="-15876" y="1422742"/>
+            <a:ext cx="9921875" cy="954093"/>
+          </a:xfrm>
+          <a:prstGeom prst="rect">
+            <a:avLst/>
+          </a:prstGeom>
+          <a:noFill/>
+          <a:ln>
+            <a:noFill/>
+          </a:ln>
+          <a:extLst>
+            <a:ext uri="{909E8E84-426E-40DD-AFC4-6F175D3DCCD1}">
+              <a14:hiddenFill xmlns:a14="http://schemas.microsoft.com/office/drawing/2010/main">
+                <a:solidFill>
+                  <a:srgbClr val="FFFFFF"/>
+                </a:solidFill>
+              </a14:hiddenFill>
+            </a:ext>
+            <a:ext uri="{91240B29-F687-4F45-9708-019B960494DF}">
+              <a14:hiddenLine xmlns:a14="http://schemas.microsoft.com/office/drawing/2010/main" w="9525">
+                <a:solidFill>
+                  <a:srgbClr val="000000"/>
+                </a:solidFill>
+                <a:miter lim="800000"/>
+                <a:headEnd/>
+                <a:tailEnd/>
+              </a14:hiddenLine>
+            </a:ext>
+          </a:extLst>
+        </p:spPr>
+        <p:txBody>
+          <a:bodyPr lIns="91426" tIns="45713" rIns="91426" bIns="45713">
+            <a:spAutoFit/>
+          </a:bodyPr>
+          <a:lstStyle>
+            <a:lvl1pPr>
+              <a:spcBef>
+                <a:spcPct val="20000"/>
+              </a:spcBef>
+              <a:buChar char="•"/>
+              <a:defRPr sz="3200">
+                <a:solidFill>
+                  <a:schemeClr val="tx1"/>
+                </a:solidFill>
+                <a:latin typeface="Arial" panose="020B0604020202020204" pitchFamily="34" charset="0"/>
+              </a:defRPr>
+            </a:lvl1pPr>
+            <a:lvl2pPr marL="742950" indent="-285750">
+              <a:spcBef>
+                <a:spcPct val="20000"/>
+              </a:spcBef>
+              <a:buChar char="–"/>
+              <a:defRPr sz="2800">
+                <a:solidFill>
+                  <a:schemeClr val="tx1"/>
+                </a:solidFill>
+                <a:latin typeface="Arial" panose="020B0604020202020204" pitchFamily="34" charset="0"/>
+              </a:defRPr>
+            </a:lvl2pPr>
+            <a:lvl3pPr marL="1143000" indent="-228600">
+              <a:spcBef>
+                <a:spcPct val="20000"/>
+              </a:spcBef>
+              <a:buChar char="•"/>
+              <a:defRPr sz="2400">
+                <a:solidFill>
+                  <a:schemeClr val="tx1"/>
+                </a:solidFill>
+                <a:latin typeface="Arial" panose="020B0604020202020204" pitchFamily="34" charset="0"/>
+              </a:defRPr>
+            </a:lvl3pPr>
+            <a:lvl4pPr marL="1600200" indent="-228600">
+              <a:spcBef>
+                <a:spcPct val="20000"/>
+              </a:spcBef>
+              <a:buChar char="–"/>
+              <a:defRPr sz="2000">
+                <a:solidFill>
+                  <a:schemeClr val="tx1"/>
+                </a:solidFill>
+                <a:latin typeface="Arial" panose="020B0604020202020204" pitchFamily="34" charset="0"/>
+              </a:defRPr>
+            </a:lvl4pPr>
+            <a:lvl5pPr marL="2057400" indent="-228600">
+              <a:spcBef>
+                <a:spcPct val="20000"/>
+              </a:spcBef>
+              <a:buChar char="»"/>
+              <a:defRPr sz="2000">
+                <a:solidFill>
+                  <a:schemeClr val="tx1"/>
+                </a:solidFill>
+                <a:latin typeface="Arial" panose="020B0604020202020204" pitchFamily="34" charset="0"/>
+              </a:defRPr>
+            </a:lvl5pPr>
+            <a:lvl6pPr marL="2514600" indent="-228600" eaLnBrk="0" fontAlgn="base" hangingPunct="0">
+              <a:spcBef>
+                <a:spcPct val="20000"/>
+              </a:spcBef>
+              <a:spcAft>
+                <a:spcPct val="0"/>
+              </a:spcAft>
+              <a:buChar char="»"/>
+              <a:defRPr sz="2000">
+                <a:solidFill>
+                  <a:schemeClr val="tx1"/>
+                </a:solidFill>
+                <a:latin typeface="Arial" panose="020B0604020202020204" pitchFamily="34" charset="0"/>
+              </a:defRPr>
+            </a:lvl6pPr>
+            <a:lvl7pPr marL="2971800" indent="-228600" eaLnBrk="0" fontAlgn="base" hangingPunct="0">
+              <a:spcBef>
+                <a:spcPct val="20000"/>
+              </a:spcBef>
+              <a:spcAft>
+                <a:spcPct val="0"/>
+              </a:spcAft>
+              <a:buChar char="»"/>
+              <a:defRPr sz="2000">
+                <a:solidFill>
+                  <a:schemeClr val="tx1"/>
+                </a:solidFill>
+                <a:latin typeface="Arial" panose="020B0604020202020204" pitchFamily="34" charset="0"/>
+              </a:defRPr>
+            </a:lvl7pPr>
+            <a:lvl8pPr marL="3429000" indent="-228600" eaLnBrk="0" fontAlgn="base" hangingPunct="0">
+              <a:spcBef>
+                <a:spcPct val="20000"/>
+              </a:spcBef>
+              <a:spcAft>
+                <a:spcPct val="0"/>
+              </a:spcAft>
+              <a:buChar char="»"/>
+              <a:defRPr sz="2000">
+                <a:solidFill>
+                  <a:schemeClr val="tx1"/>
+                </a:solidFill>
+                <a:latin typeface="Arial" panose="020B0604020202020204" pitchFamily="34" charset="0"/>
+              </a:defRPr>
+            </a:lvl8pPr>
+            <a:lvl9pPr marL="3886200" indent="-228600" eaLnBrk="0" fontAlgn="base" hangingPunct="0">
+              <a:spcBef>
+                <a:spcPct val="20000"/>
+              </a:spcBef>
+              <a:spcAft>
+                <a:spcPct val="0"/>
+              </a:spcAft>
+              <a:buChar char="»"/>
+              <a:defRPr sz="2000">
+                <a:solidFill>
+                  <a:schemeClr val="tx1"/>
+                </a:solidFill>
+                <a:latin typeface="Arial" panose="020B0604020202020204" pitchFamily="34" charset="0"/>
+              </a:defRPr>
+            </a:lvl9pPr>
+          </a:lstStyle>
+          <a:p>
+            <a:pPr algn="ctr" eaLnBrk="1" hangingPunct="1">
+              <a:spcBef>
+                <a:spcPct val="0"/>
+              </a:spcBef>
+              <a:buFontTx/>
+              <a:buNone/>
+            </a:pPr>
+            <a:r>
+              <a:rPr lang="pt-BR" altLang="pt-BR" sz="5600" b="1" dirty="0">
+                <a:latin typeface="Arial Black" panose="020B0A04020102020204" pitchFamily="34" charset="0"/>
+              </a:rPr>
+              <a:t>NOME</a:t>
+            </a:r>
+          </a:p>
+        </p:txBody>
+      </p:sp>
     </p:spTree>
   </p:cSld>
   <p:clrMapOvr>

</xml_diff>